<commit_message>
Fix screenshots that cut off numbered callouts
Show the numbered callouts only when the full set fits in the crop. Remove
partial callouts and arrows from the other crops, and widen the canvas
evidence crop so its highlight box is complete.

Co-authored-by: Copilot <223556219+Copilot@users.noreply.github.com>
</commit_message>
<xml_diff>
--- a/slides/00-setup.pptx
+++ b/slides/00-setup.pptx
@@ -12890,12 +12890,12 @@
         </p:nvSpPr>
         <p:spPr>
           <a:xfrm>
-            <a:off x="4320927" y="1610916"/>
-            <a:ext cx="4311551" cy="2467570"/>
+            <a:off x="4461867" y="1577876"/>
+            <a:ext cx="4029670" cy="2533650"/>
           </a:xfrm>
           <a:prstGeom prst="roundRect">
             <a:avLst>
-              <a:gd name="adj" fmla="val 3088"/>
+              <a:gd name="adj" fmla="val 3008"/>
             </a:avLst>
           </a:prstGeom>
           <a:solidFill>
@@ -12941,8 +12941,8 @@
         </p:blipFill>
         <p:spPr>
           <a:xfrm>
-            <a:off x="4368552" y="1658541"/>
-            <a:ext cx="4216301" cy="2372320"/>
+            <a:off x="4509492" y="1625501"/>
+            <a:ext cx="3934420" cy="2438400"/>
           </a:xfrm>
           <a:prstGeom prst="rect">
             <a:avLst/>

</xml_diff>

<commit_message>
Show the full Add GitHub repository menu in Chapter 00
Crop the screenshot to the whole Projects menu so both numbered callouts
and every menu item fit.

Co-authored-by: Copilot <223556219+Copilot@users.noreply.github.com>
</commit_message>
<xml_diff>
--- a/slides/00-setup.pptx
+++ b/slides/00-setup.pptx
@@ -12289,7 +12289,7 @@
         </p:nvSpPr>
         <p:spPr>
           <a:xfrm>
-            <a:off x="507950" y="1745307"/>
+            <a:off x="507950" y="1770757"/>
             <a:ext cx="279350" cy="279350"/>
           </a:xfrm>
           <a:prstGeom prst="roundRect">
@@ -12321,7 +12321,7 @@
         </p:nvSpPr>
         <p:spPr>
           <a:xfrm>
-            <a:off x="602615" y="1789658"/>
+            <a:off x="602615" y="1815108"/>
             <a:ext cx="90020" cy="190500"/>
           </a:xfrm>
           <a:prstGeom prst="rect">
@@ -12360,7 +12360,7 @@
         </p:nvSpPr>
         <p:spPr>
           <a:xfrm>
-            <a:off x="939701" y="1745307"/>
+            <a:off x="939701" y="1770757"/>
             <a:ext cx="3186684" cy="222200"/>
           </a:xfrm>
           <a:prstGeom prst="rect">
@@ -12402,7 +12402,7 @@
         </p:nvSpPr>
         <p:spPr>
           <a:xfrm>
-            <a:off x="939701" y="1992809"/>
+            <a:off x="939701" y="2018258"/>
             <a:ext cx="3186684" cy="613321"/>
           </a:xfrm>
           <a:prstGeom prst="rect">
@@ -12478,7 +12478,7 @@
         </p:nvSpPr>
         <p:spPr>
           <a:xfrm>
-            <a:off x="507950" y="2860030"/>
+            <a:off x="507950" y="2885480"/>
             <a:ext cx="279350" cy="279350"/>
           </a:xfrm>
           <a:prstGeom prst="roundRect">
@@ -12510,7 +12510,7 @@
         </p:nvSpPr>
         <p:spPr>
           <a:xfrm>
-            <a:off x="602615" y="2904381"/>
+            <a:off x="602615" y="2929830"/>
             <a:ext cx="90020" cy="190500"/>
           </a:xfrm>
           <a:prstGeom prst="rect">
@@ -12549,7 +12549,7 @@
         </p:nvSpPr>
         <p:spPr>
           <a:xfrm>
-            <a:off x="939701" y="2860030"/>
+            <a:off x="939701" y="2885480"/>
             <a:ext cx="3186684" cy="222200"/>
           </a:xfrm>
           <a:prstGeom prst="rect">
@@ -12591,7 +12591,7 @@
         </p:nvSpPr>
         <p:spPr>
           <a:xfrm>
-            <a:off x="939701" y="3107531"/>
+            <a:off x="939701" y="3132981"/>
             <a:ext cx="3186684" cy="396180"/>
           </a:xfrm>
           <a:prstGeom prst="rect">
@@ -12653,7 +12653,7 @@
                 <a:ea typeface="Arial" pitchFamily="34" charset="-122"/>
                 <a:cs typeface="Arial" pitchFamily="34" charset="-120"/>
               </a:rPr>
-              <a:t> next to </a:t>
+              <a:t> (1), then </a:t>
             </a:r>
             <a:pPr algn="l" indent="0" marL="0">
               <a:lnSpc>
@@ -12670,7 +12670,7 @@
                 <a:ea typeface="Arial" pitchFamily="34" charset="-122"/>
                 <a:cs typeface="Arial" pitchFamily="34" charset="-120"/>
               </a:rPr>
-              <a:t>Projects</a:t>
+              <a:t>Add GitHub repository</a:t>
             </a:r>
             <a:pPr algn="l" indent="0" marL="0">
               <a:lnSpc>
@@ -12687,41 +12687,7 @@
                 <a:ea typeface="Arial" pitchFamily="34" charset="-122"/>
                 <a:cs typeface="Arial" pitchFamily="34" charset="-120"/>
               </a:rPr>
-              <a:t>, then </a:t>
-            </a:r>
-            <a:pPr algn="l" indent="0" marL="0">
-              <a:lnSpc>
-                <a:spcPts val="1560"/>
-              </a:lnSpc>
-              <a:buNone/>
-            </a:pPr>
-            <a:r>
-              <a:rPr lang="en-US" sz="1350" b="1" dirty="0">
-                <a:solidFill>
-                  <a:srgbClr val="59636E"/>
-                </a:solidFill>
-                <a:latin typeface="Arial" pitchFamily="34" charset="0"/>
-                <a:ea typeface="Arial" pitchFamily="34" charset="-122"/>
-                <a:cs typeface="Arial" pitchFamily="34" charset="-120"/>
-              </a:rPr>
-              <a:t>Add GitHub repository</a:t>
-            </a:r>
-            <a:pPr algn="l" indent="0" marL="0">
-              <a:lnSpc>
-                <a:spcPts val="1560"/>
-              </a:lnSpc>
-              <a:buNone/>
-            </a:pPr>
-            <a:r>
-              <a:rPr lang="en-US" sz="1350" dirty="0">
-                <a:solidFill>
-                  <a:srgbClr val="59636E"/>
-                </a:solidFill>
-                <a:latin typeface="Arial" pitchFamily="34" charset="0"/>
-                <a:ea typeface="Arial" pitchFamily="34" charset="-122"/>
-                <a:cs typeface="Arial" pitchFamily="34" charset="-120"/>
-              </a:rPr>
-              <a:t>.</a:t>
+              <a:t> (2).</a:t>
             </a:r>
             <a:endParaRPr lang="en-US" sz="1350" dirty="0"/>
           </a:p>
@@ -12735,7 +12701,7 @@
         </p:nvSpPr>
         <p:spPr>
           <a:xfrm>
-            <a:off x="507950" y="3757613"/>
+            <a:off x="507950" y="3783062"/>
             <a:ext cx="279350" cy="279350"/>
           </a:xfrm>
           <a:prstGeom prst="roundRect">
@@ -12767,7 +12733,7 @@
         </p:nvSpPr>
         <p:spPr>
           <a:xfrm>
-            <a:off x="602615" y="3801963"/>
+            <a:off x="602615" y="3827413"/>
             <a:ext cx="90020" cy="190500"/>
           </a:xfrm>
           <a:prstGeom prst="rect">
@@ -12806,7 +12772,7 @@
         </p:nvSpPr>
         <p:spPr>
           <a:xfrm>
-            <a:off x="939701" y="3757613"/>
+            <a:off x="939701" y="3783062"/>
             <a:ext cx="3186684" cy="222200"/>
           </a:xfrm>
           <a:prstGeom prst="rect">
@@ -12848,7 +12814,7 @@
         </p:nvSpPr>
         <p:spPr>
           <a:xfrm>
-            <a:off x="939701" y="4005114"/>
+            <a:off x="939701" y="4030563"/>
             <a:ext cx="3186684" cy="396180"/>
           </a:xfrm>
           <a:prstGeom prst="rect">
@@ -12890,12 +12856,12 @@
         </p:nvSpPr>
         <p:spPr>
           <a:xfrm>
-            <a:off x="4461867" y="1577876"/>
-            <a:ext cx="4029670" cy="2533650"/>
+            <a:off x="4320927" y="1579811"/>
+            <a:ext cx="4311551" cy="3037731"/>
           </a:xfrm>
           <a:prstGeom prst="roundRect">
             <a:avLst>
-              <a:gd name="adj" fmla="val 3008"/>
+              <a:gd name="adj" fmla="val 2508"/>
             </a:avLst>
           </a:prstGeom>
           <a:solidFill>
@@ -12941,8 +12907,8 @@
         </p:blipFill>
         <p:spPr>
           <a:xfrm>
-            <a:off x="4509492" y="1625501"/>
-            <a:ext cx="3934420" cy="2438400"/>
+            <a:off x="4368552" y="1627436"/>
+            <a:ext cx="4216301" cy="2942481"/>
           </a:xfrm>
           <a:prstGeom prst="rect">
             <a:avLst/>

</xml_diff>

<commit_message>
Fit screenshots to their slide areas
Crop list, menu, and dialog screenshots to complete rows and controls so no
text is cut off at an edge, and remove empty margins so UI text is larger.
Replace the unreadable plugin marketplace capture with a clean summary card.

Co-authored-by: Copilot <223556219+Copilot@users.noreply.github.com>
</commit_message>
<xml_diff>
--- a/slides/00-setup.pptx
+++ b/slides/00-setup.pptx
@@ -11527,12 +11527,12 @@
         </p:nvSpPr>
         <p:spPr>
           <a:xfrm>
-            <a:off x="4320927" y="1950690"/>
-            <a:ext cx="4311551" cy="1940421"/>
+            <a:off x="4320927" y="1974056"/>
+            <a:ext cx="4311551" cy="1893540"/>
           </a:xfrm>
           <a:prstGeom prst="roundRect">
             <a:avLst>
-              <a:gd name="adj" fmla="val 3927"/>
+              <a:gd name="adj" fmla="val 4024"/>
             </a:avLst>
           </a:prstGeom>
           <a:solidFill>
@@ -11564,7 +11564,7 @@
       </p:sp>
       <p:pic>
         <p:nvPicPr>
-          <p:cNvPr id="21" name="Image 2" descr="/Users/danwahlin/.copilot/session-state/56a7a0da-def8-48d4-b5e8-0ac3878cb8dd/files/slides-build/img/00-app-sign-in.png">    </p:cNvPr>
+          <p:cNvPr id="21" name="Image 2" descr="/Users/danwahlin/.copilot/session-state/56a7a0da-def8-48d4-b5e8-0ac3878cb8dd/files/slides-build/img/00-sign-in-crop.png">    </p:cNvPr>
           <p:cNvPicPr>
             <a:picLocks noChangeAspect="1"/>
           </p:cNvPicPr>
@@ -11578,8 +11578,8 @@
         </p:blipFill>
         <p:spPr>
           <a:xfrm>
-            <a:off x="4368552" y="1998315"/>
-            <a:ext cx="4216301" cy="1845171"/>
+            <a:off x="4368552" y="2021681"/>
+            <a:ext cx="4216301" cy="1798290"/>
           </a:xfrm>
           <a:prstGeom prst="rect">
             <a:avLst/>

</xml_diff>

<commit_message>
Add patterned gradients to the chapter slide decks
Title slides now use a blue splash in the top-right and a small green glow
in the bottom-left, both with flowing white lines and a dot grid. The corner
glow on every other slide uses the same pattern.

Co-authored-by: Copilot <223556219+Copilot@users.noreply.github.com>
</commit_message>
<xml_diff>
--- a/slides/00-setup.pptx
+++ b/slides/00-setup.pptx
@@ -2034,7 +2034,7 @@
       </p:grpSpPr>
       <p:pic>
         <p:nvPicPr>
-          <p:cNvPr id="2" name="Image 0" descr="/Users/danwahlin/.copilot/session-state/56a7a0da-def8-48d4-b5e8-0ac3878cb8dd/files/slides-build/img/grad-title.jpg">    </p:cNvPr>
+          <p:cNvPr id="2" name="Image 0" descr="/Users/danwahlin/.copilot/session-state/56a7a0da-def8-48d4-b5e8-0ac3878cb8dd/files/slides-build/img/grad-title-pattern.jpg">    </p:cNvPr>
           <p:cNvPicPr>
             <a:picLocks noChangeAspect="1"/>
           </p:cNvPicPr>
@@ -2446,7 +2446,7 @@
       </p:sp>
       <p:pic>
         <p:nvPicPr>
-          <p:cNvPr id="5" name="Image 0" descr="/Users/danwahlin/.copilot/session-state/56a7a0da-def8-48d4-b5e8-0ac3878cb8dd/files/slides-build/img/grad-corner.png">    </p:cNvPr>
+          <p:cNvPr id="5" name="Image 0" descr="/Users/danwahlin/.copilot/session-state/56a7a0da-def8-48d4-b5e8-0ac3878cb8dd/files/slides-build/img/grad-corner-pattern.png">    </p:cNvPr>
           <p:cNvPicPr>
             <a:picLocks noChangeAspect="1"/>
           </p:cNvPicPr>
@@ -2757,7 +2757,7 @@
       </p:grpSpPr>
       <p:pic>
         <p:nvPicPr>
-          <p:cNvPr id="2" name="Image 0" descr="/Users/danwahlin/.copilot/session-state/56a7a0da-def8-48d4-b5e8-0ac3878cb8dd/files/slides-build/img/grad-corner.png">    </p:cNvPr>
+          <p:cNvPr id="2" name="Image 0" descr="/Users/danwahlin/.copilot/session-state/56a7a0da-def8-48d4-b5e8-0ac3878cb8dd/files/slides-build/img/grad-corner-pattern.png">    </p:cNvPr>
           <p:cNvPicPr>
             <a:picLocks noChangeAspect="1"/>
           </p:cNvPicPr>
@@ -4106,7 +4106,7 @@
       </p:grpSpPr>
       <p:pic>
         <p:nvPicPr>
-          <p:cNvPr id="2" name="Image 0" descr="/Users/danwahlin/.copilot/session-state/56a7a0da-def8-48d4-b5e8-0ac3878cb8dd/files/slides-build/img/grad-corner.png">    </p:cNvPr>
+          <p:cNvPr id="2" name="Image 0" descr="/Users/danwahlin/.copilot/session-state/56a7a0da-def8-48d4-b5e8-0ac3878cb8dd/files/slides-build/img/grad-corner-pattern.png">    </p:cNvPr>
           <p:cNvPicPr>
             <a:picLocks noChangeAspect="1"/>
           </p:cNvPicPr>
@@ -5626,7 +5626,7 @@
       </p:grpSpPr>
       <p:pic>
         <p:nvPicPr>
-          <p:cNvPr id="2" name="Image 0" descr="/Users/danwahlin/.copilot/session-state/56a7a0da-def8-48d4-b5e8-0ac3878cb8dd/files/slides-build/img/grad-corner.png">    </p:cNvPr>
+          <p:cNvPr id="2" name="Image 0" descr="/Users/danwahlin/.copilot/session-state/56a7a0da-def8-48d4-b5e8-0ac3878cb8dd/files/slides-build/img/grad-corner-pattern.png">    </p:cNvPr>
           <p:cNvPicPr>
             <a:picLocks noChangeAspect="1"/>
           </p:cNvPicPr>
@@ -6290,7 +6290,7 @@
       </p:grpSpPr>
       <p:pic>
         <p:nvPicPr>
-          <p:cNvPr id="2" name="Image 0" descr="/Users/danwahlin/.copilot/session-state/56a7a0da-def8-48d4-b5e8-0ac3878cb8dd/files/slides-build/img/grad-corner.png">    </p:cNvPr>
+          <p:cNvPr id="2" name="Image 0" descr="/Users/danwahlin/.copilot/session-state/56a7a0da-def8-48d4-b5e8-0ac3878cb8dd/files/slides-build/img/grad-corner-pattern.png">    </p:cNvPr>
           <p:cNvPicPr>
             <a:picLocks noChangeAspect="1"/>
           </p:cNvPicPr>
@@ -7419,7 +7419,7 @@
       </p:grpSpPr>
       <p:pic>
         <p:nvPicPr>
-          <p:cNvPr id="2" name="Image 0" descr="/Users/danwahlin/.copilot/session-state/56a7a0da-def8-48d4-b5e8-0ac3878cb8dd/files/slides-build/img/grad-corner.png">    </p:cNvPr>
+          <p:cNvPr id="2" name="Image 0" descr="/Users/danwahlin/.copilot/session-state/56a7a0da-def8-48d4-b5e8-0ac3878cb8dd/files/slides-build/img/grad-corner-pattern.png">    </p:cNvPr>
           <p:cNvPicPr>
             <a:picLocks noChangeAspect="1"/>
           </p:cNvPicPr>
@@ -8388,7 +8388,7 @@
       </p:grpSpPr>
       <p:pic>
         <p:nvPicPr>
-          <p:cNvPr id="2" name="Image 0" descr="/Users/danwahlin/.copilot/session-state/56a7a0da-def8-48d4-b5e8-0ac3878cb8dd/files/slides-build/img/grad-corner.png">    </p:cNvPr>
+          <p:cNvPr id="2" name="Image 0" descr="/Users/danwahlin/.copilot/session-state/56a7a0da-def8-48d4-b5e8-0ac3878cb8dd/files/slides-build/img/grad-corner-pattern.png">    </p:cNvPr>
           <p:cNvPicPr>
             <a:picLocks noChangeAspect="1"/>
           </p:cNvPicPr>
@@ -9285,7 +9285,7 @@
       </p:grpSpPr>
       <p:pic>
         <p:nvPicPr>
-          <p:cNvPr id="2" name="Image 0" descr="/Users/danwahlin/.copilot/session-state/56a7a0da-def8-48d4-b5e8-0ac3878cb8dd/files/slides-build/img/grad-corner.png">    </p:cNvPr>
+          <p:cNvPr id="2" name="Image 0" descr="/Users/danwahlin/.copilot/session-state/56a7a0da-def8-48d4-b5e8-0ac3878cb8dd/files/slides-build/img/grad-corner-pattern.png">    </p:cNvPr>
           <p:cNvPicPr>
             <a:picLocks noChangeAspect="1"/>
           </p:cNvPicPr>
@@ -10438,7 +10438,7 @@
       </p:sp>
       <p:pic>
         <p:nvPicPr>
-          <p:cNvPr id="5" name="Image 0" descr="/Users/danwahlin/.copilot/session-state/56a7a0da-def8-48d4-b5e8-0ac3878cb8dd/files/slides-build/img/grad-corner.png">    </p:cNvPr>
+          <p:cNvPr id="5" name="Image 0" descr="/Users/danwahlin/.copilot/session-state/56a7a0da-def8-48d4-b5e8-0ac3878cb8dd/files/slides-build/img/grad-corner-pattern.png">    </p:cNvPr>
           <p:cNvPicPr>
             <a:picLocks noChangeAspect="1"/>
           </p:cNvPicPr>
@@ -10749,7 +10749,7 @@
       </p:grpSpPr>
       <p:pic>
         <p:nvPicPr>
-          <p:cNvPr id="2" name="Image 0" descr="/Users/danwahlin/.copilot/session-state/56a7a0da-def8-48d4-b5e8-0ac3878cb8dd/files/slides-build/img/grad-corner.png">    </p:cNvPr>
+          <p:cNvPr id="2" name="Image 0" descr="/Users/danwahlin/.copilot/session-state/56a7a0da-def8-48d4-b5e8-0ac3878cb8dd/files/slides-build/img/grad-corner-pattern.png">    </p:cNvPr>
           <p:cNvPicPr>
             <a:picLocks noChangeAspect="1"/>
           </p:cNvPicPr>
@@ -11722,7 +11722,7 @@
       </p:sp>
       <p:pic>
         <p:nvPicPr>
-          <p:cNvPr id="5" name="Image 0" descr="/Users/danwahlin/.copilot/session-state/56a7a0da-def8-48d4-b5e8-0ac3878cb8dd/files/slides-build/img/grad-corner.png">    </p:cNvPr>
+          <p:cNvPr id="5" name="Image 0" descr="/Users/danwahlin/.copilot/session-state/56a7a0da-def8-48d4-b5e8-0ac3878cb8dd/files/slides-build/img/grad-corner-pattern.png">    </p:cNvPr>
           <p:cNvPicPr>
             <a:picLocks noChangeAspect="1"/>
           </p:cNvPicPr>
@@ -12033,7 +12033,7 @@
       </p:grpSpPr>
       <p:pic>
         <p:nvPicPr>
-          <p:cNvPr id="2" name="Image 0" descr="/Users/danwahlin/.copilot/session-state/56a7a0da-def8-48d4-b5e8-0ac3878cb8dd/files/slides-build/img/grad-corner.png">    </p:cNvPr>
+          <p:cNvPr id="2" name="Image 0" descr="/Users/danwahlin/.copilot/session-state/56a7a0da-def8-48d4-b5e8-0ac3878cb8dd/files/slides-build/img/grad-corner-pattern.png">    </p:cNvPr>
           <p:cNvPicPr>
             <a:picLocks noChangeAspect="1"/>
           </p:cNvPicPr>
@@ -12949,7 +12949,7 @@
       </p:grpSpPr>
       <p:pic>
         <p:nvPicPr>
-          <p:cNvPr id="2" name="Image 0" descr="/Users/danwahlin/.copilot/session-state/56a7a0da-def8-48d4-b5e8-0ac3878cb8dd/files/slides-build/img/grad-corner.png">    </p:cNvPr>
+          <p:cNvPr id="2" name="Image 0" descr="/Users/danwahlin/.copilot/session-state/56a7a0da-def8-48d4-b5e8-0ac3878cb8dd/files/slides-build/img/grad-corner-pattern.png">    </p:cNvPr>
           <p:cNvPicPr>
             <a:picLocks noChangeAspect="1"/>
           </p:cNvPicPr>

</xml_diff>

<commit_message>
Add accessible alt text to slide deck images
Screenshots and illustrations now use the alt text from the course
chapters. The GitHub link icons describe their link. Gradients and
icons are marked as decorative. This replaces the local file paths
that were used as alt text.

Co-authored-by: Copilot <223556219+Copilot@users.noreply.github.com>
</commit_message>
<xml_diff>
--- a/slides/00-setup.pptx
+++ b/slides/00-setup.pptx
@@ -2034,7 +2034,13 @@
       </p:grpSpPr>
       <p:pic>
         <p:nvPicPr>
-          <p:cNvPr id="2" name="Image 0" descr="/Users/danwahlin/.copilot/session-state/56a7a0da-def8-48d4-b5e8-0ac3878cb8dd/files/slides-build/img/grad-title-pattern.jpg">    </p:cNvPr>
+          <p:cNvPr id="2" name="Image 0" descr="">
+            <a:extLst>
+              <a:ext uri="{C183D7F6-B498-43B3-948B-1728B52AA6E4}">
+                <adec:decorative xmlns:adec="http://schemas.microsoft.com/office/drawing/2017/decorative" val="1"/>
+              </a:ext>
+            </a:extLst>
+          </p:cNvPr>
           <p:cNvPicPr>
             <a:picLocks noChangeAspect="1"/>
           </p:cNvPicPr>
@@ -2058,7 +2064,7 @@
       </p:pic>
       <p:pic>
         <p:nvPicPr>
-          <p:cNvPr id="3" name="Image 1" descr="/Users/danwahlin/.copilot/session-state/56a7a0da-def8-48d4-b5e8-0ac3878cb8dd/files/slides-build/icons/FaGithub-1F2328.png">
+          <p:cNvPr id="3" name="Image 1" descr="Open this chapter on GitHub">
             <a:hlinkClick r:id="rId3" tooltip="https://github.com/github/copilot-app-for-beginners/tree/main/00-setup"/>
           </p:cNvPr>
           <p:cNvPicPr>
@@ -2242,7 +2248,13 @@
       </p:sp>
       <p:pic>
         <p:nvPicPr>
-          <p:cNvPr id="8" name="Image 2" descr="/Users/danwahlin/.copilot/session-state/56a7a0da-def8-48d4-b5e8-0ac3878cb8dd/files/slides-build/icons/FaGithub-0969DA.png">    </p:cNvPr>
+          <p:cNvPr id="8" name="Image 2" descr="">
+            <a:extLst>
+              <a:ext uri="{C183D7F6-B498-43B3-948B-1728B52AA6E4}">
+                <adec:decorative xmlns:adec="http://schemas.microsoft.com/office/drawing/2017/decorative" val="1"/>
+              </a:ext>
+            </a:extLst>
+          </p:cNvPr>
           <p:cNvPicPr>
             <a:picLocks noChangeAspect="1"/>
           </p:cNvPicPr>
@@ -2446,7 +2458,13 @@
       </p:sp>
       <p:pic>
         <p:nvPicPr>
-          <p:cNvPr id="5" name="Image 0" descr="/Users/danwahlin/.copilot/session-state/56a7a0da-def8-48d4-b5e8-0ac3878cb8dd/files/slides-build/img/grad-corner-pattern.png">    </p:cNvPr>
+          <p:cNvPr id="5" name="Image 0" descr="">
+            <a:extLst>
+              <a:ext uri="{C183D7F6-B498-43B3-948B-1728B52AA6E4}">
+                <adec:decorative xmlns:adec="http://schemas.microsoft.com/office/drawing/2017/decorative" val="1"/>
+              </a:ext>
+            </a:extLst>
+          </p:cNvPr>
           <p:cNvPicPr>
             <a:picLocks noChangeAspect="1"/>
           </p:cNvPicPr>
@@ -2541,7 +2559,7 @@
       </p:sp>
       <p:pic>
         <p:nvPicPr>
-          <p:cNvPr id="8" name="Image 1" descr="/Users/danwahlin/.copilot/session-state/56a7a0da-def8-48d4-b5e8-0ac3878cb8dd/files/slides-build/icons/FaGithub-1F2328.png">
+          <p:cNvPr id="8" name="Image 1" descr="Open this chapter on GitHub">
             <a:hlinkClick r:id="rId3" tooltip="https://github.com/github/copilot-app-for-beginners/tree/main/00-setup"/>
           </p:cNvPr>
           <p:cNvPicPr>
@@ -2757,7 +2775,13 @@
       </p:grpSpPr>
       <p:pic>
         <p:nvPicPr>
-          <p:cNvPr id="2" name="Image 0" descr="/Users/danwahlin/.copilot/session-state/56a7a0da-def8-48d4-b5e8-0ac3878cb8dd/files/slides-build/img/grad-corner-pattern.png">    </p:cNvPr>
+          <p:cNvPr id="2" name="Image 0" descr="">
+            <a:extLst>
+              <a:ext uri="{C183D7F6-B498-43B3-948B-1728B52AA6E4}">
+                <adec:decorative xmlns:adec="http://schemas.microsoft.com/office/drawing/2017/decorative" val="1"/>
+              </a:ext>
+            </a:extLst>
+          </p:cNvPr>
           <p:cNvPicPr>
             <a:picLocks noChangeAspect="1"/>
           </p:cNvPicPr>
@@ -2852,7 +2876,7 @@
       </p:sp>
       <p:pic>
         <p:nvPicPr>
-          <p:cNvPr id="5" name="Image 1" descr="/Users/danwahlin/.copilot/session-state/56a7a0da-def8-48d4-b5e8-0ac3878cb8dd/files/slides-build/icons/FaGithub-1F2328.png">
+          <p:cNvPr id="5" name="Image 1" descr="Open this chapter on GitHub">
             <a:hlinkClick r:id="rId3" tooltip="https://github.com/github/copilot-app-for-beginners/tree/main/00-setup"/>
           </p:cNvPr>
           <p:cNvPicPr>
@@ -3756,7 +3780,13 @@
       </p:sp>
       <p:pic>
         <p:nvPicPr>
-          <p:cNvPr id="24" name="Image 2" descr="/Users/danwahlin/.copilot/session-state/56a7a0da-def8-48d4-b5e8-0ac3878cb8dd/files/slides-build/icons/GoCheckCircle-1A7F37.png">    </p:cNvPr>
+          <p:cNvPr id="24" name="Image 2" descr="">
+            <a:extLst>
+              <a:ext uri="{C183D7F6-B498-43B3-948B-1728B52AA6E4}">
+                <adec:decorative xmlns:adec="http://schemas.microsoft.com/office/drawing/2017/decorative" val="1"/>
+              </a:ext>
+            </a:extLst>
+          </p:cNvPr>
           <p:cNvPicPr>
             <a:picLocks noChangeAspect="1"/>
           </p:cNvPicPr>
@@ -3932,7 +3962,13 @@
       </p:sp>
       <p:pic>
         <p:nvPicPr>
-          <p:cNvPr id="29" name="Image 3" descr="/Users/danwahlin/.copilot/session-state/56a7a0da-def8-48d4-b5e8-0ac3878cb8dd/files/slides-build/icons/GoPerson-0969DA.png">    </p:cNvPr>
+          <p:cNvPr id="29" name="Image 3" descr="">
+            <a:extLst>
+              <a:ext uri="{C183D7F6-B498-43B3-948B-1728B52AA6E4}">
+                <adec:decorative xmlns:adec="http://schemas.microsoft.com/office/drawing/2017/decorative" val="1"/>
+              </a:ext>
+            </a:extLst>
+          </p:cNvPr>
           <p:cNvPicPr>
             <a:picLocks noChangeAspect="1"/>
           </p:cNvPicPr>
@@ -4106,7 +4142,13 @@
       </p:grpSpPr>
       <p:pic>
         <p:nvPicPr>
-          <p:cNvPr id="2" name="Image 0" descr="/Users/danwahlin/.copilot/session-state/56a7a0da-def8-48d4-b5e8-0ac3878cb8dd/files/slides-build/img/grad-corner-pattern.png">    </p:cNvPr>
+          <p:cNvPr id="2" name="Image 0" descr="">
+            <a:extLst>
+              <a:ext uri="{C183D7F6-B498-43B3-948B-1728B52AA6E4}">
+                <adec:decorative xmlns:adec="http://schemas.microsoft.com/office/drawing/2017/decorative" val="1"/>
+              </a:ext>
+            </a:extLst>
+          </p:cNvPr>
           <p:cNvPicPr>
             <a:picLocks noChangeAspect="1"/>
           </p:cNvPicPr>
@@ -4201,7 +4243,7 @@
       </p:sp>
       <p:pic>
         <p:nvPicPr>
-          <p:cNvPr id="5" name="Image 1" descr="/Users/danwahlin/.copilot/session-state/56a7a0da-def8-48d4-b5e8-0ac3878cb8dd/files/slides-build/icons/FaGithub-1F2328.png">
+          <p:cNvPr id="5" name="Image 1" descr="Open this chapter on GitHub">
             <a:hlinkClick r:id="rId3" tooltip="https://github.com/github/copilot-app-for-beginners/tree/main/00-setup"/>
           </p:cNvPr>
           <p:cNvPicPr>
@@ -5096,7 +5138,13 @@
       </p:sp>
       <p:pic>
         <p:nvPicPr>
-          <p:cNvPr id="27" name="Image 2" descr="/Users/danwahlin/.copilot/session-state/56a7a0da-def8-48d4-b5e8-0ac3878cb8dd/files/slides-build/icons/GoTasklist-1A7F37.png">    </p:cNvPr>
+          <p:cNvPr id="27" name="Image 2" descr="">
+            <a:extLst>
+              <a:ext uri="{C183D7F6-B498-43B3-948B-1728B52AA6E4}">
+                <adec:decorative xmlns:adec="http://schemas.microsoft.com/office/drawing/2017/decorative" val="1"/>
+              </a:ext>
+            </a:extLst>
+          </p:cNvPr>
           <p:cNvPicPr>
             <a:picLocks noChangeAspect="1"/>
           </p:cNvPicPr>
@@ -5494,7 +5542,13 @@
       </p:sp>
       <p:pic>
         <p:nvPicPr>
-          <p:cNvPr id="38" name="Image 3" descr="/Users/danwahlin/.copilot/session-state/56a7a0da-def8-48d4-b5e8-0ac3878cb8dd/files/slides-build/icons/GoAlert-9A6700.png">    </p:cNvPr>
+          <p:cNvPr id="38" name="Image 3" descr="">
+            <a:extLst>
+              <a:ext uri="{C183D7F6-B498-43B3-948B-1728B52AA6E4}">
+                <adec:decorative xmlns:adec="http://schemas.microsoft.com/office/drawing/2017/decorative" val="1"/>
+              </a:ext>
+            </a:extLst>
+          </p:cNvPr>
           <p:cNvPicPr>
             <a:picLocks noChangeAspect="1"/>
           </p:cNvPicPr>
@@ -5626,7 +5680,13 @@
       </p:grpSpPr>
       <p:pic>
         <p:nvPicPr>
-          <p:cNvPr id="2" name="Image 0" descr="/Users/danwahlin/.copilot/session-state/56a7a0da-def8-48d4-b5e8-0ac3878cb8dd/files/slides-build/img/grad-corner-pattern.png">    </p:cNvPr>
+          <p:cNvPr id="2" name="Image 0" descr="">
+            <a:extLst>
+              <a:ext uri="{C183D7F6-B498-43B3-948B-1728B52AA6E4}">
+                <adec:decorative xmlns:adec="http://schemas.microsoft.com/office/drawing/2017/decorative" val="1"/>
+              </a:ext>
+            </a:extLst>
+          </p:cNvPr>
           <p:cNvPicPr>
             <a:picLocks noChangeAspect="1"/>
           </p:cNvPicPr>
@@ -5721,7 +5781,7 @@
       </p:sp>
       <p:pic>
         <p:nvPicPr>
-          <p:cNvPr id="5" name="Image 1" descr="/Users/danwahlin/.copilot/session-state/56a7a0da-def8-48d4-b5e8-0ac3878cb8dd/files/slides-build/icons/FaGithub-1F2328.png">
+          <p:cNvPr id="5" name="Image 1" descr="Open this chapter on GitHub">
             <a:hlinkClick r:id="rId3" tooltip="https://github.com/github/copilot-app-for-beginners/tree/main/00-setup"/>
           </p:cNvPr>
           <p:cNvPicPr>
@@ -6000,7 +6060,13 @@
       </p:sp>
       <p:pic>
         <p:nvPicPr>
-          <p:cNvPr id="14" name="Image 2" descr="/Users/danwahlin/.copilot/session-state/56a7a0da-def8-48d4-b5e8-0ac3878cb8dd/files/slides-build/icons/GoCopilot-8250DF.png">    </p:cNvPr>
+          <p:cNvPr id="14" name="Image 2" descr="">
+            <a:extLst>
+              <a:ext uri="{C183D7F6-B498-43B3-948B-1728B52AA6E4}">
+                <adec:decorative xmlns:adec="http://schemas.microsoft.com/office/drawing/2017/decorative" val="1"/>
+              </a:ext>
+            </a:extLst>
+          </p:cNvPr>
           <p:cNvPicPr>
             <a:picLocks noChangeAspect="1"/>
           </p:cNvPicPr>
@@ -6141,7 +6207,13 @@
       </p:sp>
       <p:pic>
         <p:nvPicPr>
-          <p:cNvPr id="18" name="Image 3" descr="/Users/danwahlin/.copilot/session-state/56a7a0da-def8-48d4-b5e8-0ac3878cb8dd/files/slides-build/icons/GoCheckCircle-1A7F37.png">    </p:cNvPr>
+          <p:cNvPr id="18" name="Image 3" descr="">
+            <a:extLst>
+              <a:ext uri="{C183D7F6-B498-43B3-948B-1728B52AA6E4}">
+                <adec:decorative xmlns:adec="http://schemas.microsoft.com/office/drawing/2017/decorative" val="1"/>
+              </a:ext>
+            </a:extLst>
+          </p:cNvPr>
           <p:cNvPicPr>
             <a:picLocks noChangeAspect="1"/>
           </p:cNvPicPr>
@@ -6290,7 +6362,13 @@
       </p:grpSpPr>
       <p:pic>
         <p:nvPicPr>
-          <p:cNvPr id="2" name="Image 0" descr="/Users/danwahlin/.copilot/session-state/56a7a0da-def8-48d4-b5e8-0ac3878cb8dd/files/slides-build/img/grad-corner-pattern.png">    </p:cNvPr>
+          <p:cNvPr id="2" name="Image 0" descr="">
+            <a:extLst>
+              <a:ext uri="{C183D7F6-B498-43B3-948B-1728B52AA6E4}">
+                <adec:decorative xmlns:adec="http://schemas.microsoft.com/office/drawing/2017/decorative" val="1"/>
+              </a:ext>
+            </a:extLst>
+          </p:cNvPr>
           <p:cNvPicPr>
             <a:picLocks noChangeAspect="1"/>
           </p:cNvPicPr>
@@ -6385,7 +6463,7 @@
       </p:sp>
       <p:pic>
         <p:nvPicPr>
-          <p:cNvPr id="5" name="Image 1" descr="/Users/danwahlin/.copilot/session-state/56a7a0da-def8-48d4-b5e8-0ac3878cb8dd/files/slides-build/icons/FaGithub-1F2328.png">
+          <p:cNvPr id="5" name="Image 1" descr="Open this chapter on GitHub">
             <a:hlinkClick r:id="rId3" tooltip="https://github.com/github/copilot-app-for-beginners/tree/main/00-setup"/>
           </p:cNvPr>
           <p:cNvPicPr>
@@ -7193,7 +7271,13 @@
       </p:sp>
       <p:pic>
         <p:nvPicPr>
-          <p:cNvPr id="26" name="Image 2" descr="/Users/danwahlin/.copilot/session-state/56a7a0da-def8-48d4-b5e8-0ac3878cb8dd/files/slides-build/icons/FaGithub-0969DA.png">    </p:cNvPr>
+          <p:cNvPr id="26" name="Image 2" descr="">
+            <a:extLst>
+              <a:ext uri="{C183D7F6-B498-43B3-948B-1728B52AA6E4}">
+                <adec:decorative xmlns:adec="http://schemas.microsoft.com/office/drawing/2017/decorative" val="1"/>
+              </a:ext>
+            </a:extLst>
+          </p:cNvPr>
           <p:cNvPicPr>
             <a:picLocks noChangeAspect="1"/>
           </p:cNvPicPr>
@@ -7419,7 +7503,13 @@
       </p:grpSpPr>
       <p:pic>
         <p:nvPicPr>
-          <p:cNvPr id="2" name="Image 0" descr="/Users/danwahlin/.copilot/session-state/56a7a0da-def8-48d4-b5e8-0ac3878cb8dd/files/slides-build/img/grad-corner-pattern.png">    </p:cNvPr>
+          <p:cNvPr id="2" name="Image 0" descr="">
+            <a:extLst>
+              <a:ext uri="{C183D7F6-B498-43B3-948B-1728B52AA6E4}">
+                <adec:decorative xmlns:adec="http://schemas.microsoft.com/office/drawing/2017/decorative" val="1"/>
+              </a:ext>
+            </a:extLst>
+          </p:cNvPr>
           <p:cNvPicPr>
             <a:picLocks noChangeAspect="1"/>
           </p:cNvPicPr>
@@ -7514,7 +7604,7 @@
       </p:sp>
       <p:pic>
         <p:nvPicPr>
-          <p:cNvPr id="5" name="Image 1" descr="/Users/danwahlin/.copilot/session-state/56a7a0da-def8-48d4-b5e8-0ac3878cb8dd/files/slides-build/icons/FaGithub-1F2328.png">
+          <p:cNvPr id="5" name="Image 1" descr="Open this chapter on GitHub">
             <a:hlinkClick r:id="rId3" tooltip="https://github.com/github/copilot-app-for-beginners/tree/main/00-setup"/>
           </p:cNvPr>
           <p:cNvPicPr>
@@ -8388,7 +8478,13 @@
       </p:grpSpPr>
       <p:pic>
         <p:nvPicPr>
-          <p:cNvPr id="2" name="Image 0" descr="/Users/danwahlin/.copilot/session-state/56a7a0da-def8-48d4-b5e8-0ac3878cb8dd/files/slides-build/img/grad-corner-pattern.png">    </p:cNvPr>
+          <p:cNvPr id="2" name="Image 0" descr="">
+            <a:extLst>
+              <a:ext uri="{C183D7F6-B498-43B3-948B-1728B52AA6E4}">
+                <adec:decorative xmlns:adec="http://schemas.microsoft.com/office/drawing/2017/decorative" val="1"/>
+              </a:ext>
+            </a:extLst>
+          </p:cNvPr>
           <p:cNvPicPr>
             <a:picLocks noChangeAspect="1"/>
           </p:cNvPicPr>
@@ -8483,7 +8579,7 @@
       </p:sp>
       <p:pic>
         <p:nvPicPr>
-          <p:cNvPr id="5" name="Image 1" descr="/Users/danwahlin/.copilot/session-state/56a7a0da-def8-48d4-b5e8-0ac3878cb8dd/files/slides-build/icons/FaGithub-1F2328.png">
+          <p:cNvPr id="5" name="Image 1" descr="Open this chapter on GitHub">
             <a:hlinkClick r:id="rId3" tooltip="https://github.com/github/copilot-app-for-beginners/tree/main/00-setup"/>
           </p:cNvPr>
           <p:cNvPicPr>
@@ -8681,7 +8777,7 @@
       </p:sp>
       <p:pic>
         <p:nvPicPr>
-          <p:cNvPr id="10" name="Image 2" descr="/Users/danwahlin/.copilot/session-state/56a7a0da-def8-48d4-b5e8-0ac3878cb8dd/files/slides-build/img/00-studio-setup-soundcheck.jpg">    </p:cNvPr>
+          <p:cNvPr id="10" name="Image 2" descr="Setting up the studio analogy for GitHub Copilot app setup">    </p:cNvPr>
           <p:cNvPicPr>
             <a:picLocks noChangeAspect="1"/>
           </p:cNvPicPr>
@@ -8737,7 +8833,13 @@
       </p:sp>
       <p:pic>
         <p:nvPicPr>
-          <p:cNvPr id="12" name="Image 3" descr="/Users/danwahlin/.copilot/session-state/56a7a0da-def8-48d4-b5e8-0ac3878cb8dd/files/slides-build/icons/FaGithub-0969DA.png">    </p:cNvPr>
+          <p:cNvPr id="12" name="Image 3" descr="">
+            <a:extLst>
+              <a:ext uri="{C183D7F6-B498-43B3-948B-1728B52AA6E4}">
+                <adec:decorative xmlns:adec="http://schemas.microsoft.com/office/drawing/2017/decorative" val="1"/>
+              </a:ext>
+            </a:extLst>
+          </p:cNvPr>
           <p:cNvPicPr>
             <a:picLocks noChangeAspect="1"/>
           </p:cNvPicPr>
@@ -8874,7 +8976,13 @@
       </p:sp>
       <p:pic>
         <p:nvPicPr>
-          <p:cNvPr id="16" name="Image 4" descr="/Users/danwahlin/.copilot/session-state/56a7a0da-def8-48d4-b5e8-0ac3878cb8dd/files/slides-build/icons/GoPlug-8250DF.png">    </p:cNvPr>
+          <p:cNvPr id="16" name="Image 4" descr="">
+            <a:extLst>
+              <a:ext uri="{C183D7F6-B498-43B3-948B-1728B52AA6E4}">
+                <adec:decorative xmlns:adec="http://schemas.microsoft.com/office/drawing/2017/decorative" val="1"/>
+              </a:ext>
+            </a:extLst>
+          </p:cNvPr>
           <p:cNvPicPr>
             <a:picLocks noChangeAspect="1"/>
           </p:cNvPicPr>
@@ -9011,7 +9119,13 @@
       </p:sp>
       <p:pic>
         <p:nvPicPr>
-          <p:cNvPr id="20" name="Image 5" descr="/Users/danwahlin/.copilot/session-state/56a7a0da-def8-48d4-b5e8-0ac3878cb8dd/files/slides-build/icons/GoTasklist-1A7F37.png">    </p:cNvPr>
+          <p:cNvPr id="20" name="Image 5" descr="">
+            <a:extLst>
+              <a:ext uri="{C183D7F6-B498-43B3-948B-1728B52AA6E4}">
+                <adec:decorative xmlns:adec="http://schemas.microsoft.com/office/drawing/2017/decorative" val="1"/>
+              </a:ext>
+            </a:extLst>
+          </p:cNvPr>
           <p:cNvPicPr>
             <a:picLocks noChangeAspect="1"/>
           </p:cNvPicPr>
@@ -9148,7 +9262,13 @@
       </p:sp>
       <p:pic>
         <p:nvPicPr>
-          <p:cNvPr id="24" name="Image 6" descr="/Users/danwahlin/.copilot/session-state/56a7a0da-def8-48d4-b5e8-0ac3878cb8dd/files/slides-build/icons/GoCopilot-BC4C00.png">    </p:cNvPr>
+          <p:cNvPr id="24" name="Image 6" descr="">
+            <a:extLst>
+              <a:ext uri="{C183D7F6-B498-43B3-948B-1728B52AA6E4}">
+                <adec:decorative xmlns:adec="http://schemas.microsoft.com/office/drawing/2017/decorative" val="1"/>
+              </a:ext>
+            </a:extLst>
+          </p:cNvPr>
           <p:cNvPicPr>
             <a:picLocks noChangeAspect="1"/>
           </p:cNvPicPr>
@@ -9285,7 +9405,13 @@
       </p:grpSpPr>
       <p:pic>
         <p:nvPicPr>
-          <p:cNvPr id="2" name="Image 0" descr="/Users/danwahlin/.copilot/session-state/56a7a0da-def8-48d4-b5e8-0ac3878cb8dd/files/slides-build/img/grad-corner-pattern.png">    </p:cNvPr>
+          <p:cNvPr id="2" name="Image 0" descr="">
+            <a:extLst>
+              <a:ext uri="{C183D7F6-B498-43B3-948B-1728B52AA6E4}">
+                <adec:decorative xmlns:adec="http://schemas.microsoft.com/office/drawing/2017/decorative" val="1"/>
+              </a:ext>
+            </a:extLst>
+          </p:cNvPr>
           <p:cNvPicPr>
             <a:picLocks noChangeAspect="1"/>
           </p:cNvPicPr>
@@ -9380,7 +9506,7 @@
       </p:sp>
       <p:pic>
         <p:nvPicPr>
-          <p:cNvPr id="5" name="Image 1" descr="/Users/danwahlin/.copilot/session-state/56a7a0da-def8-48d4-b5e8-0ac3878cb8dd/files/slides-build/icons/FaGithub-1F2328.png">
+          <p:cNvPr id="5" name="Image 1" descr="Open this chapter on GitHub">
             <a:hlinkClick r:id="rId3" tooltip="https://github.com/github/copilot-app-for-beginners/tree/main/00-setup"/>
           </p:cNvPr>
           <p:cNvPicPr>
@@ -10221,7 +10347,13 @@
       </p:sp>
       <p:pic>
         <p:nvPicPr>
-          <p:cNvPr id="25" name="Image 2" descr="/Users/danwahlin/.copilot/session-state/56a7a0da-def8-48d4-b5e8-0ac3878cb8dd/files/slides-build/icons/GoInfo-0969DA.png">    </p:cNvPr>
+          <p:cNvPr id="25" name="Image 2" descr="">
+            <a:extLst>
+              <a:ext uri="{C183D7F6-B498-43B3-948B-1728B52AA6E4}">
+                <adec:decorative xmlns:adec="http://schemas.microsoft.com/office/drawing/2017/decorative" val="1"/>
+              </a:ext>
+            </a:extLst>
+          </p:cNvPr>
           <p:cNvPicPr>
             <a:picLocks noChangeAspect="1"/>
           </p:cNvPicPr>
@@ -10438,7 +10570,13 @@
       </p:sp>
       <p:pic>
         <p:nvPicPr>
-          <p:cNvPr id="5" name="Image 0" descr="/Users/danwahlin/.copilot/session-state/56a7a0da-def8-48d4-b5e8-0ac3878cb8dd/files/slides-build/img/grad-corner-pattern.png">    </p:cNvPr>
+          <p:cNvPr id="5" name="Image 0" descr="">
+            <a:extLst>
+              <a:ext uri="{C183D7F6-B498-43B3-948B-1728B52AA6E4}">
+                <adec:decorative xmlns:adec="http://schemas.microsoft.com/office/drawing/2017/decorative" val="1"/>
+              </a:ext>
+            </a:extLst>
+          </p:cNvPr>
           <p:cNvPicPr>
             <a:picLocks noChangeAspect="1"/>
           </p:cNvPicPr>
@@ -10533,7 +10671,7 @@
       </p:sp>
       <p:pic>
         <p:nvPicPr>
-          <p:cNvPr id="8" name="Image 1" descr="/Users/danwahlin/.copilot/session-state/56a7a0da-def8-48d4-b5e8-0ac3878cb8dd/files/slides-build/icons/FaGithub-1F2328.png">
+          <p:cNvPr id="8" name="Image 1" descr="Open this chapter on GitHub">
             <a:hlinkClick r:id="rId3" tooltip="https://github.com/github/copilot-app-for-beginners/tree/main/00-setup"/>
           </p:cNvPr>
           <p:cNvPicPr>
@@ -10749,7 +10887,13 @@
       </p:grpSpPr>
       <p:pic>
         <p:nvPicPr>
-          <p:cNvPr id="2" name="Image 0" descr="/Users/danwahlin/.copilot/session-state/56a7a0da-def8-48d4-b5e8-0ac3878cb8dd/files/slides-build/img/grad-corner-pattern.png">    </p:cNvPr>
+          <p:cNvPr id="2" name="Image 0" descr="">
+            <a:extLst>
+              <a:ext uri="{C183D7F6-B498-43B3-948B-1728B52AA6E4}">
+                <adec:decorative xmlns:adec="http://schemas.microsoft.com/office/drawing/2017/decorative" val="1"/>
+              </a:ext>
+            </a:extLst>
+          </p:cNvPr>
           <p:cNvPicPr>
             <a:picLocks noChangeAspect="1"/>
           </p:cNvPicPr>
@@ -10844,7 +10988,7 @@
       </p:sp>
       <p:pic>
         <p:nvPicPr>
-          <p:cNvPr id="5" name="Image 1" descr="/Users/danwahlin/.copilot/session-state/56a7a0da-def8-48d4-b5e8-0ac3878cb8dd/files/slides-build/icons/FaGithub-1F2328.png">
+          <p:cNvPr id="5" name="Image 1" descr="Open this chapter on GitHub">
             <a:hlinkClick r:id="rId3" tooltip="https://github.com/github/copilot-app-for-beginners/tree/main/00-setup"/>
           </p:cNvPr>
           <p:cNvPicPr>
@@ -11564,7 +11708,7 @@
       </p:sp>
       <p:pic>
         <p:nvPicPr>
-          <p:cNvPr id="21" name="Image 2" descr="/Users/danwahlin/.copilot/session-state/56a7a0da-def8-48d4-b5e8-0ac3878cb8dd/files/slides-build/img/00-sign-in-crop.png">    </p:cNvPr>
+          <p:cNvPr id="21" name="Image 2" descr="Sign in to the Copilot app">    </p:cNvPr>
           <p:cNvPicPr>
             <a:picLocks noChangeAspect="1"/>
           </p:cNvPicPr>
@@ -11722,7 +11866,13 @@
       </p:sp>
       <p:pic>
         <p:nvPicPr>
-          <p:cNvPr id="5" name="Image 0" descr="/Users/danwahlin/.copilot/session-state/56a7a0da-def8-48d4-b5e8-0ac3878cb8dd/files/slides-build/img/grad-corner-pattern.png">    </p:cNvPr>
+          <p:cNvPr id="5" name="Image 0" descr="">
+            <a:extLst>
+              <a:ext uri="{C183D7F6-B498-43B3-948B-1728B52AA6E4}">
+                <adec:decorative xmlns:adec="http://schemas.microsoft.com/office/drawing/2017/decorative" val="1"/>
+              </a:ext>
+            </a:extLst>
+          </p:cNvPr>
           <p:cNvPicPr>
             <a:picLocks noChangeAspect="1"/>
           </p:cNvPicPr>
@@ -11817,7 +11967,7 @@
       </p:sp>
       <p:pic>
         <p:nvPicPr>
-          <p:cNvPr id="8" name="Image 1" descr="/Users/danwahlin/.copilot/session-state/56a7a0da-def8-48d4-b5e8-0ac3878cb8dd/files/slides-build/icons/FaGithub-1F2328.png">
+          <p:cNvPr id="8" name="Image 1" descr="Open this chapter on GitHub">
             <a:hlinkClick r:id="rId3" tooltip="https://github.com/github/copilot-app-for-beginners/tree/main/00-setup"/>
           </p:cNvPr>
           <p:cNvPicPr>
@@ -12033,7 +12183,13 @@
       </p:grpSpPr>
       <p:pic>
         <p:nvPicPr>
-          <p:cNvPr id="2" name="Image 0" descr="/Users/danwahlin/.copilot/session-state/56a7a0da-def8-48d4-b5e8-0ac3878cb8dd/files/slides-build/img/grad-corner-pattern.png">    </p:cNvPr>
+          <p:cNvPr id="2" name="Image 0" descr="">
+            <a:extLst>
+              <a:ext uri="{C183D7F6-B498-43B3-948B-1728B52AA6E4}">
+                <adec:decorative xmlns:adec="http://schemas.microsoft.com/office/drawing/2017/decorative" val="1"/>
+              </a:ext>
+            </a:extLst>
+          </p:cNvPr>
           <p:cNvPicPr>
             <a:picLocks noChangeAspect="1"/>
           </p:cNvPicPr>
@@ -12128,7 +12284,7 @@
       </p:sp>
       <p:pic>
         <p:nvPicPr>
-          <p:cNvPr id="5" name="Image 1" descr="/Users/danwahlin/.copilot/session-state/56a7a0da-def8-48d4-b5e8-0ac3878cb8dd/files/slides-build/icons/FaGithub-1F2328.png">
+          <p:cNvPr id="5" name="Image 1" descr="Open this chapter on GitHub">
             <a:hlinkClick r:id="rId3" tooltip="https://github.com/github/copilot-app-for-beginners/tree/main/00-setup"/>
           </p:cNvPr>
           <p:cNvPicPr>
@@ -12893,7 +13049,7 @@
       </p:sp>
       <p:pic>
         <p:nvPicPr>
-          <p:cNvPr id="22" name="Image 2" descr="/Users/danwahlin/.copilot/session-state/56a7a0da-def8-48d4-b5e8-0ac3878cb8dd/files/slides-build/img/00-add-project-crop.png">    </p:cNvPr>
+          <p:cNvPr id="22" name="Image 2" descr="Projects menu with callouts for + and Add GitHub repository">    </p:cNvPr>
           <p:cNvPicPr>
             <a:picLocks noChangeAspect="1"/>
           </p:cNvPicPr>
@@ -12949,7 +13105,13 @@
       </p:grpSpPr>
       <p:pic>
         <p:nvPicPr>
-          <p:cNvPr id="2" name="Image 0" descr="/Users/danwahlin/.copilot/session-state/56a7a0da-def8-48d4-b5e8-0ac3878cb8dd/files/slides-build/img/grad-corner-pattern.png">    </p:cNvPr>
+          <p:cNvPr id="2" name="Image 0" descr="">
+            <a:extLst>
+              <a:ext uri="{C183D7F6-B498-43B3-948B-1728B52AA6E4}">
+                <adec:decorative xmlns:adec="http://schemas.microsoft.com/office/drawing/2017/decorative" val="1"/>
+              </a:ext>
+            </a:extLst>
+          </p:cNvPr>
           <p:cNvPicPr>
             <a:picLocks noChangeAspect="1"/>
           </p:cNvPicPr>
@@ -13044,7 +13206,7 @@
       </p:sp>
       <p:pic>
         <p:nvPicPr>
-          <p:cNvPr id="5" name="Image 1" descr="/Users/danwahlin/.copilot/session-state/56a7a0da-def8-48d4-b5e8-0ac3878cb8dd/files/slides-build/icons/FaGithub-1F2328.png">
+          <p:cNvPr id="5" name="Image 1" descr="Open this chapter on GitHub">
             <a:hlinkClick r:id="rId3" tooltip="https://github.com/github/copilot-app-for-beginners/tree/main/00-setup"/>
           </p:cNvPr>
           <p:cNvPicPr>
@@ -13242,7 +13404,7 @@
       </p:sp>
       <p:pic>
         <p:nvPicPr>
-          <p:cNvPr id="10" name="Image 2" descr="/Users/danwahlin/.copilot/session-state/56a7a0da-def8-48d4-b5e8-0ac3878cb8dd/files/slides-build/img/00-checkout-crop.png">    </p:cNvPr>
+          <p:cNvPr id="10" name="Image 2" descr="Where to work menu with callouts for the workspace selector and Current checkout">    </p:cNvPr>
           <p:cNvPicPr>
             <a:picLocks noChangeAspect="1"/>
           </p:cNvPicPr>

</xml_diff>